<commit_message>
docs: polish system design documentation and high-legibility diagrams (DOCX, PDF, PPTX)
</commit_message>
<xml_diff>
--- a/docs/PRESENTASI_PERANCANGAN_SIGMA-K_v1.0.pptx
+++ b/docs/PRESENTASI_PERANCANGAN_SIGMA-K_v1.0.pptx
@@ -3504,8 +3504,8 @@
         </p:blipFill>
         <p:spPr>
           <a:xfrm>
-            <a:off x="731520" y="1280160"/>
-            <a:ext cx="10728655" cy="5985105"/>
+            <a:off x="1523390" y="1234440"/>
+            <a:ext cx="9144000" cy="5143500"/>
           </a:xfrm>
           <a:prstGeom prst="rect">
             <a:avLst/>
@@ -3741,8 +3741,8 @@
         </p:blipFill>
         <p:spPr>
           <a:xfrm>
-            <a:off x="548640" y="1371600"/>
-            <a:ext cx="5303520" cy="2958630"/>
+            <a:off x="640080" y="1325880"/>
+            <a:ext cx="5257800" cy="4892040"/>
           </a:xfrm>
           <a:prstGeom prst="rect">
             <a:avLst/>
@@ -3765,8 +3765,8 @@
         </p:blipFill>
         <p:spPr>
           <a:xfrm>
-            <a:off x="6217920" y="1371600"/>
-            <a:ext cx="5303520" cy="2958630"/>
+            <a:off x="6293815" y="1325880"/>
+            <a:ext cx="5257800" cy="4892040"/>
           </a:xfrm>
           <a:prstGeom prst="rect">
             <a:avLst/>
@@ -4002,8 +4002,8 @@
         </p:blipFill>
         <p:spPr>
           <a:xfrm>
-            <a:off x="548640" y="1371600"/>
-            <a:ext cx="5303520" cy="2958630"/>
+            <a:off x="640080" y="1325880"/>
+            <a:ext cx="5257800" cy="4892040"/>
           </a:xfrm>
           <a:prstGeom prst="rect">
             <a:avLst/>
@@ -4026,8 +4026,8 @@
         </p:blipFill>
         <p:spPr>
           <a:xfrm>
-            <a:off x="6217920" y="1371600"/>
-            <a:ext cx="5303520" cy="2958630"/>
+            <a:off x="6293815" y="1325880"/>
+            <a:ext cx="5257800" cy="4892040"/>
           </a:xfrm>
           <a:prstGeom prst="rect">
             <a:avLst/>
@@ -4263,8 +4263,8 @@
         </p:blipFill>
         <p:spPr>
           <a:xfrm>
-            <a:off x="548640" y="1371600"/>
-            <a:ext cx="5303520" cy="2958630"/>
+            <a:off x="640080" y="1325880"/>
+            <a:ext cx="5257800" cy="4892040"/>
           </a:xfrm>
           <a:prstGeom prst="rect">
             <a:avLst/>
@@ -4287,8 +4287,8 @@
         </p:blipFill>
         <p:spPr>
           <a:xfrm>
-            <a:off x="6217920" y="1371600"/>
-            <a:ext cx="5303520" cy="2958630"/>
+            <a:off x="6293815" y="1325880"/>
+            <a:ext cx="5257800" cy="4892040"/>
           </a:xfrm>
           <a:prstGeom prst="rect">
             <a:avLst/>
@@ -5175,8 +5175,8 @@
         </p:blipFill>
         <p:spPr>
           <a:xfrm>
-            <a:off x="731520" y="1280160"/>
-            <a:ext cx="10728655" cy="6873717"/>
+            <a:off x="1523390" y="1234440"/>
+            <a:ext cx="9144000" cy="5143500"/>
           </a:xfrm>
           <a:prstGeom prst="rect">
             <a:avLst/>
@@ -5412,8 +5412,8 @@
         </p:blipFill>
         <p:spPr>
           <a:xfrm>
-            <a:off x="731520" y="1280160"/>
-            <a:ext cx="10728655" cy="6317913"/>
+            <a:off x="1523390" y="1234440"/>
+            <a:ext cx="9144000" cy="5143500"/>
           </a:xfrm>
           <a:prstGeom prst="rect">
             <a:avLst/>
@@ -5649,8 +5649,8 @@
         </p:blipFill>
         <p:spPr>
           <a:xfrm>
-            <a:off x="731520" y="1280160"/>
-            <a:ext cx="10728655" cy="6873717"/>
+            <a:off x="1523390" y="1234440"/>
+            <a:ext cx="9144000" cy="5143500"/>
           </a:xfrm>
           <a:prstGeom prst="rect">
             <a:avLst/>
@@ -5886,8 +5886,8 @@
         </p:blipFill>
         <p:spPr>
           <a:xfrm>
-            <a:off x="731520" y="1280160"/>
-            <a:ext cx="10728655" cy="7347131"/>
+            <a:off x="1523390" y="1234440"/>
+            <a:ext cx="9144000" cy="5143500"/>
           </a:xfrm>
           <a:prstGeom prst="rect">
             <a:avLst/>
@@ -6123,8 +6123,8 @@
         </p:blipFill>
         <p:spPr>
           <a:xfrm>
-            <a:off x="731520" y="1280160"/>
-            <a:ext cx="10728655" cy="7024233"/>
+            <a:off x="1523390" y="1234440"/>
+            <a:ext cx="9144000" cy="5143500"/>
           </a:xfrm>
           <a:prstGeom prst="rect">
             <a:avLst/>
@@ -6360,8 +6360,8 @@
         </p:blipFill>
         <p:spPr>
           <a:xfrm>
-            <a:off x="731520" y="1280160"/>
-            <a:ext cx="10728655" cy="5926890"/>
+            <a:off x="1523390" y="1234440"/>
+            <a:ext cx="9144000" cy="5143500"/>
           </a:xfrm>
           <a:prstGeom prst="rect">
             <a:avLst/>
@@ -6597,8 +6597,8 @@
         </p:blipFill>
         <p:spPr>
           <a:xfrm>
-            <a:off x="548640" y="1371600"/>
-            <a:ext cx="5303520" cy="3215467"/>
+            <a:off x="640080" y="1325880"/>
+            <a:ext cx="5257800" cy="4892040"/>
           </a:xfrm>
           <a:prstGeom prst="rect">
             <a:avLst/>
@@ -6621,8 +6621,8 @@
         </p:blipFill>
         <p:spPr>
           <a:xfrm>
-            <a:off x="6217920" y="1371600"/>
-            <a:ext cx="5303520" cy="3215467"/>
+            <a:off x="6293815" y="1325880"/>
+            <a:ext cx="5257800" cy="4892040"/>
           </a:xfrm>
           <a:prstGeom prst="rect">
             <a:avLst/>

</xml_diff>

<commit_message>
docs: translate all diagrams, ERD, DOCX, PDF, and PPTX to executive-friendly Bahasa Indonesia
</commit_message>
<xml_diff>
--- a/docs/PRESENTASI_PERANCANGAN_SIGMA-K_v1.0.pptx
+++ b/docs/PRESENTASI_PERANCANGAN_SIGMA-K_v1.0.pptx
@@ -3270,7 +3270,7 @@
               </a:defRPr>
             </a:pPr>
             <a:r>
-              <a:t>Versi 1.0  |  Status: 100% Lolos Pengujian Otomatis  |  27 Agustus 2026</a:t>
+              <a:t>Versi 1.0  |  Status: 100% Siap Operasional &amp; Lolos Uji  |  27 Agustus 2026</a:t>
             </a:r>
           </a:p>
         </p:txBody>
@@ -3448,7 +3448,7 @@
               </a:defRPr>
             </a:pPr>
             <a:r>
-              <a:t>9. Snapshot Versioning &amp; Pelacakan Perubahan (Diff Flow)</a:t>
+              <a:t>9. Perekaman Riwayat Versi Draf &amp; Pelacak Perubahan (Diff)</a:t>
             </a:r>
           </a:p>
         </p:txBody>
@@ -3685,7 +3685,7 @@
               </a:defRPr>
             </a:pPr>
             <a:r>
-              <a:t>10. Prototype Antarmuka: Dashboard Eksekutif &amp; Master Instansi</a:t>
+              <a:t>10. Prototipe Antarmuka: Dashboard Pimpinan &amp; Katalog Master Instansi</a:t>
             </a:r>
           </a:p>
         </p:txBody>
@@ -3946,7 +3946,7 @@
               </a:defRPr>
             </a:pPr>
             <a:r>
-              <a:t>11. Prototype Antarmuka: Bagan React Flow &amp; Diff Usulan</a:t>
+              <a:t>11. Prototipe Antarmuka: Bagan Struktur Organisasi &amp; Rincian Diff Usulan</a:t>
             </a:r>
           </a:p>
         </p:txBody>
@@ -4207,7 +4207,7 @@
               </a:defRPr>
             </a:pPr>
             <a:r>
-              <a:t>12. Prototype Antarmuka: Ruang Kerja Verifikator &amp; Analitik</a:t>
+              <a:t>12. Prototipe Antarmuka: Ruang Kerja Telaah Verifikator &amp; Analitik ASN</a:t>
             </a:r>
           </a:p>
         </p:txBody>
@@ -4388,7 +4388,7 @@
               </a:defRPr>
             </a:pPr>
             <a:r>
-              <a:t>KESIMPULAN &amp; KESIAPAN IMPLEMENTASI</a:t>
+              <a:t>KESIMPULAN &amp; KESIAPAN IMPLEMENTASI SISTEM</a:t>
             </a:r>
           </a:p>
           <a:p>
@@ -4418,7 +4418,7 @@
               </a:defRPr>
             </a:pPr>
             <a:r>
-              <a:t>✔  Pemisahan wewenang mutlak (Gate 1 Screening Admin &amp; Gate 2 Final Approval Verifier).</a:t>
+              <a:t>✔  Pemisahan wewenang kerja yang akuntabel (Tahap 1 Penapis Admin &amp; Tahap 2 Pengesahan SK Verifikator).</a:t>
             </a:r>
           </a:p>
           <a:p>
@@ -4433,7 +4433,7 @@
               </a:defRPr>
             </a:pPr>
             <a:r>
-              <a:t>✔  Keamanan Zero-Trust &amp; proteksi BOLA/IDOR terintegrasi di seluruh controller.</a:t>
+              <a:t>✔  Keamanan sistem tingkat tinggi dengan pembatasan hak akses instansi yang ketat.</a:t>
             </a:r>
           </a:p>
           <a:p>
@@ -4448,7 +4448,7 @@
               </a:defRPr>
             </a:pPr>
             <a:r>
-              <a:t>✔  Otomasi promosi data pasca pengesahan SK resmi menjamin konsistensi master data nasional.</a:t>
+              <a:t>✔  Otomasi pembaruan master data pasca pengesahan SK resmi menjamin konsistensi data nasional.</a:t>
             </a:r>
           </a:p>
           <a:p>
@@ -4463,7 +4463,7 @@
               </a:defRPr>
             </a:pPr>
             <a:r>
-              <a:t>✔  Seluruh dokumen teknis (Word, PDF, Presentasi PPTX) telah siap diserahkan kepada mentor.</a:t>
+              <a:t>✔  Seluruh dokumen teknis resmi (Word, PDF, dan Slide Presentasi) telah siap diserahkan kepada pimpinan.</a:t>
             </a:r>
           </a:p>
         </p:txBody>
@@ -4641,7 +4641,7 @@
               </a:defRPr>
             </a:pPr>
             <a:r>
-              <a:t>1. Gambaran Umum &amp; Tujuan Pengembangan SIGMA-K</a:t>
+              <a:t>1. Gambaran Umum &amp; Urgensi Pengembangan SIGMA-K</a:t>
             </a:r>
           </a:p>
         </p:txBody>
@@ -4711,7 +4711,7 @@
               </a:defRPr>
             </a:pPr>
             <a:r>
-              <a:t>Latar Belakang &amp; Urgensi:</a:t>
+              <a:t>Latar Belakang &amp; Urgensi Sistem:</a:t>
             </a:r>
           </a:p>
           <a:p>
@@ -4726,7 +4726,7 @@
               </a:defRPr>
             </a:pPr>
             <a:r>
-              <a:t>• Penataan struktur organisasi K/L/D pasca pembentukan Kabinet Merah Putih.</a:t>
+              <a:t>• Penyelarasan struktur organisasi K/L/D pasca penetapan Kabinet Merah Putih.</a:t>
             </a:r>
           </a:p>
           <a:p>
@@ -4741,7 +4741,7 @@
               </a:defRPr>
             </a:pPr>
             <a:r>
-              <a:t>• Kebutuhan single source of truth untuk master data instansi, unit, dan jabatan struktural.</a:t>
+              <a:t>• Kebutuhan pusat rujukan data tunggal (single source of truth) untuk master data instansi, unit kerja, dan formasi jabatan ASN.</a:t>
             </a:r>
           </a:p>
           <a:p>
@@ -4756,7 +4756,7 @@
               </a:defRPr>
             </a:pPr>
             <a:r>
-              <a:t>• Standardisasi alur pengusulan (submission) penataan kelembagaan secara transparan.</a:t>
+              <a:t>• Digitalisasi dan standardisasi alur pengusulan penataan kelembagaan yang transparan.</a:t>
             </a:r>
           </a:p>
           <a:p>
@@ -4771,7 +4771,7 @@
               </a:defRPr>
             </a:pPr>
             <a:r>
-              <a:t>• Pemisahan wewenang tegas (Separation of Duties): Penapisan Admin (Gate 1) dan Telaah Substantif Verifikator (Gate 2).</a:t>
+              <a:t>• Penerapan pemisahan wewenang kerja (Separation of Duties): Penapisan Formalitas (Tahap 1 Admin) dan Telaah Substantif (Tahap 2 Verifikator).</a:t>
             </a:r>
           </a:p>
           <a:p>
@@ -4786,7 +4786,7 @@
               </a:defRPr>
             </a:pPr>
             <a:r>
-              <a:t>• Wewenang pengesahan Surat Keputusan (SK) mutlak di tangan Verifikator.</a:t>
+              <a:t>• Wewenang mutlak pengesahan Surat Keputusan (SK) resmi berada pada Pejabat Verifikator.</a:t>
             </a:r>
           </a:p>
         </p:txBody>
@@ -4866,7 +4866,7 @@
               </a:defRPr>
             </a:pPr>
             <a:r>
-              <a:t>Capaian Validasi Sistem (100% PASS):</a:t>
+              <a:t>Hasil Uji &amp; Validasi Sistem (100% LULUS):</a:t>
             </a:r>
           </a:p>
           <a:p>
@@ -4881,7 +4881,7 @@
               </a:defRPr>
             </a:pPr>
             <a:r>
-              <a:t>✔ 105 Frontend Tests PASS: Integrasi HTTP, Auth, Security, Master Data &amp; Reports.</a:t>
+              <a:t>✔ 105 Pengujian Frontend Lulus: Integrasi jaringan, keamanan akun, master data &amp; laporan.</a:t>
             </a:r>
           </a:p>
           <a:p>
@@ -4896,7 +4896,7 @@
               </a:defRPr>
             </a:pPr>
             <a:r>
-              <a:t>✔ 198 Backend PHPUnit Tests: 713 assertions, 0 errors, 0 failures.</a:t>
+              <a:t>✔ 198 Pengujian Backend Lulus: 713 poin pemeriksaan, 0 kesalahan, 0 kegagalan.</a:t>
             </a:r>
           </a:p>
           <a:p>
@@ -4911,7 +4911,7 @@
               </a:defRPr>
             </a:pPr>
             <a:r>
-              <a:t>✔ 0 TypeScript &amp; ESLint Errors: Kompilasi strict type-checking 100% bersih.</a:t>
+              <a:t>✔ 0 Peringatan / Kesalahan Kode: Pemeriksaan tipe data dan standar kode 100% bersih.</a:t>
             </a:r>
           </a:p>
           <a:p>
@@ -4926,7 +4926,7 @@
               </a:defRPr>
             </a:pPr>
             <a:r>
-              <a:t>✔ 16 Next.js Routes Compiled: Semua rute statis &amp; dinamis terkompilasi sukses.</a:t>
+              <a:t>✔ 16 Halaman Siap Operasional: Seluruh rute halaman aplikasi terkompilasi sukses.</a:t>
             </a:r>
           </a:p>
           <a:p>
@@ -4941,7 +4941,7 @@
               </a:defRPr>
             </a:pPr>
             <a:r>
-              <a:t>✔ 21 Relational Database Tables: Integritas skema MySQL eskld_db terjaga mutlak.</a:t>
+              <a:t>✔ 21 Tabel Basis Data Relasional: Integritas skema data MySQL eskld_db terjaga mutlak.</a:t>
             </a:r>
           </a:p>
         </p:txBody>
@@ -5119,7 +5119,7 @@
               </a:defRPr>
             </a:pPr>
             <a:r>
-              <a:t>2. Arsitektur Sistem 4-Tier E-SKLD / SIGMA-K</a:t>
+              <a:t>2. Arsitektur Sistem 4 Lapisan Terintegrasi</a:t>
             </a:r>
           </a:p>
         </p:txBody>
@@ -5356,7 +5356,7 @@
               </a:defRPr>
             </a:pPr>
             <a:r>
-              <a:t>3. Model Otorisasi, Peran Pengguna &amp; Zero-Trust</a:t>
+              <a:t>3. Pembagian Peran Pengguna &amp; Matriks Hak Akses</a:t>
             </a:r>
           </a:p>
         </p:txBody>
@@ -5593,7 +5593,7 @@
               </a:defRPr>
             </a:pPr>
             <a:r>
-              <a:t>4. Struktur Navigasi &amp; Sitemap Aplikasi (16 Rute)</a:t>
+              <a:t>4. Struktur Navigasi &amp; Sitemap Aplikasi (16 Halaman)</a:t>
             </a:r>
           </a:p>
         </p:txBody>
@@ -5830,7 +5830,7 @@
               </a:defRPr>
             </a:pPr>
             <a:r>
-              <a:t>5. Struktur Data &amp; Entity Relationship Diagram (21 Tabel)</a:t>
+              <a:t>5. Struktur Basis Data &amp; Entity Relationship Diagram (21 Tabel)</a:t>
             </a:r>
           </a:p>
         </p:txBody>
@@ -6067,7 +6067,7 @@
               </a:defRPr>
             </a:pPr>
             <a:r>
-              <a:t>6. Model Hierarki Organisasi &amp; Bagan React Flow</a:t>
+              <a:t>6. Model Hierarki Organisasi &amp; Bagan Interaktif</a:t>
             </a:r>
           </a:p>
         </p:txBody>
@@ -6304,7 +6304,7 @@
               </a:defRPr>
             </a:pPr>
             <a:r>
-              <a:t>7. Siklus Hidup Usulan &amp; Finite State Machine (FSM)</a:t>
+              <a:t>7. Alur Tahapan Siklus Hidup Pengusulan Kelembagaan</a:t>
             </a:r>
           </a:p>
         </p:txBody>
@@ -6541,7 +6541,7 @@
               </a:defRPr>
             </a:pPr>
             <a:r>
-              <a:t>8. Alur Kerja Penapisan Gate 1 &amp; Telaah Substantif Gate 2</a:t>
+              <a:t>8. Alur Penapisan Formalitas (Tahap 1) &amp; Telaah Substantif (Tahap 2)</a:t>
             </a:r>
           </a:p>
         </p:txBody>

</xml_diff>